<commit_message>
Complete conference paper and project validation tools
</commit_message>
<xml_diff>
--- a/outputs/presentation/FDM_Defect_Detection_Project.pptx
+++ b/outputs/presentation/FDM_Defect_Detection_Project.pptx
@@ -3873,7 +3873,7 @@
               </a:defRPr>
             </a:pPr>
             <a:r>
-              <a:t>- Upload image prediction</a:t>
+              <a:t>- Continuous OpenCV camera scanning</a:t>
             </a:r>
           </a:p>
           <a:p>
@@ -3888,7 +3888,7 @@
               </a:defRPr>
             </a:pPr>
             <a:r>
-              <a:t>- Live webcam monitoring</a:t>
+              <a:t>- Five-prediction temporal averaging</a:t>
             </a:r>
           </a:p>
           <a:p>
@@ -3903,7 +3903,7 @@
               </a:defRPr>
             </a:pPr>
             <a:r>
-              <a:t>- Camera snapshot fallback</a:t>
+              <a:t>- Uncertainty warning below 60%</a:t>
             </a:r>
           </a:p>
           <a:p>
@@ -3918,7 +3918,7 @@
               </a:defRPr>
             </a:pPr>
             <a:r>
-              <a:t>- Confidence chart</a:t>
+              <a:t>- AI feedback and risk level</a:t>
             </a:r>
           </a:p>
           <a:p>
@@ -3933,7 +3933,7 @@
               </a:defRPr>
             </a:pPr>
             <a:r>
-              <a:t>- AI feedback with risk level</a:t>
+              <a:t>- Axis and nozzle inspection guidance</a:t>
             </a:r>
           </a:p>
           <a:p>
@@ -3948,7 +3948,7 @@
               </a:defRPr>
             </a:pPr>
             <a:r>
-              <a:t>- Possible causes and corrective actions</a:t>
+              <a:t>- Optional OctoPrint telemetry</a:t>
             </a:r>
           </a:p>
         </p:txBody>
@@ -3998,22 +3998,22 @@
               <a:spcAft>
                 <a:spcPts val="700"/>
               </a:spcAft>
-              <a:defRPr sz="1800">
+              <a:defRPr sz="1700">
                 <a:solidFill>
                   <a:srgbClr val="F2F6FA"/>
                 </a:solidFill>
               </a:defRPr>
             </a:pPr>
             <a:r>
-              <a:t>Launch command</a:t>
-            </a:r>
-          </a:p>
-          <a:p>
-            <a:pPr>
-              <a:spcAft>
-                <a:spcPts val="700"/>
-              </a:spcAft>
-              <a:defRPr sz="1800">
+              <a:t>Recommended launch</a:t>
+            </a:r>
+          </a:p>
+          <a:p>
+            <a:pPr>
+              <a:spcAft>
+                <a:spcPts val="700"/>
+              </a:spcAft>
+              <a:defRPr sz="1700">
                 <a:solidFill>
                   <a:srgbClr val="B2BECD"/>
                 </a:solidFill>
@@ -4028,34 +4028,34 @@
               <a:spcAft>
                 <a:spcPts val="700"/>
               </a:spcAft>
-              <a:defRPr sz="1800">
-                <a:solidFill>
-                  <a:srgbClr val="B2BECD"/>
-                </a:solidFill>
-              </a:defRPr>
-            </a:pPr>
-            <a:r>
-              <a:t>.venv/bin/streamlit run src/app.py</a:t>
-            </a:r>
-          </a:p>
-          <a:p>
-            <a:pPr>
-              <a:spcAft>
-                <a:spcPts val="700"/>
-              </a:spcAft>
-              <a:defRPr sz="1800">
-                <a:solidFill>
-                  <a:srgbClr val="B2BECD"/>
-                </a:solidFill>
-              </a:defRPr>
-            </a:pPr>
-          </a:p>
-          <a:p>
-            <a:pPr>
-              <a:spcAft>
-                <a:spcPts val="700"/>
-              </a:spcAft>
-              <a:defRPr sz="1800">
+              <a:defRPr sz="1700">
+                <a:solidFill>
+                  <a:srgbClr val="B2BECD"/>
+                </a:solidFill>
+              </a:defRPr>
+            </a:pPr>
+            <a:r>
+              <a:t>.venv/bin/python src/live_dashboard.py</a:t>
+            </a:r>
+          </a:p>
+          <a:p>
+            <a:pPr>
+              <a:spcAft>
+                <a:spcPts val="700"/>
+              </a:spcAft>
+              <a:defRPr sz="1700">
+                <a:solidFill>
+                  <a:srgbClr val="B2BECD"/>
+                </a:solidFill>
+              </a:defRPr>
+            </a:pPr>
+          </a:p>
+          <a:p>
+            <a:pPr>
+              <a:spcAft>
+                <a:spcPts val="700"/>
+              </a:spcAft>
+              <a:defRPr sz="1700">
                 <a:solidFill>
                   <a:srgbClr val="B2BECD"/>
                 </a:solidFill>
@@ -4070,14 +4070,41 @@
               <a:spcAft>
                 <a:spcPts val="700"/>
               </a:spcAft>
-              <a:defRPr sz="1800">
-                <a:solidFill>
-                  <a:srgbClr val="B2BECD"/>
-                </a:solidFill>
-              </a:defRPr>
-            </a:pPr>
-            <a:r>
-              <a:t>http://localhost:8501</a:t>
+              <a:defRPr sz="1700">
+                <a:solidFill>
+                  <a:srgbClr val="B2BECD"/>
+                </a:solidFill>
+              </a:defRPr>
+            </a:pPr>
+            <a:r>
+              <a:t>http://127.0.0.1:8765</a:t>
+            </a:r>
+          </a:p>
+          <a:p>
+            <a:pPr>
+              <a:spcAft>
+                <a:spcPts val="700"/>
+              </a:spcAft>
+              <a:defRPr sz="1700">
+                <a:solidFill>
+                  <a:srgbClr val="B2BECD"/>
+                </a:solidFill>
+              </a:defRPr>
+            </a:pPr>
+          </a:p>
+          <a:p>
+            <a:pPr>
+              <a:spcAft>
+                <a:spcPts val="700"/>
+              </a:spcAft>
+              <a:defRPr sz="1700">
+                <a:solidFill>
+                  <a:srgbClr val="B2BECD"/>
+                </a:solidFill>
+              </a:defRPr>
+            </a:pPr>
+            <a:r>
+              <a:t>Camera releases when page closes</a:t>
             </a:r>
           </a:p>
         </p:txBody>
@@ -4173,7 +4200,7 @@
               </a:defRPr>
             </a:pPr>
             <a:r>
-              <a:t>AI Feedback Layer</a:t>
+              <a:t>AI Feedback and Telemetry</a:t>
             </a:r>
           </a:p>
         </p:txBody>
@@ -4223,7 +4250,7 @@
               <a:spcAft>
                 <a:spcPts val="700"/>
               </a:spcAft>
-              <a:defRPr sz="2000">
+              <a:defRPr sz="1900">
                 <a:solidFill>
                   <a:srgbClr val="F2F6FA"/>
                 </a:solidFill>
@@ -4238,89 +4265,89 @@
               <a:spcAft>
                 <a:spcPts val="700"/>
               </a:spcAft>
-              <a:defRPr sz="2000">
-                <a:solidFill>
-                  <a:srgbClr val="B2BECD"/>
-                </a:solidFill>
-              </a:defRPr>
-            </a:pPr>
-            <a:r>
-              <a:t>- Predicts the defect class</a:t>
-            </a:r>
-          </a:p>
-          <a:p>
-            <a:pPr>
-              <a:spcAft>
-                <a:spcPts val="700"/>
-              </a:spcAft>
-              <a:defRPr sz="2000">
-                <a:solidFill>
-                  <a:srgbClr val="B2BECD"/>
-                </a:solidFill>
-              </a:defRPr>
-            </a:pPr>
-            <a:r>
-              <a:t>- Reports confidence percentage</a:t>
-            </a:r>
-          </a:p>
-          <a:p>
-            <a:pPr>
-              <a:spcAft>
-                <a:spcPts val="700"/>
-              </a:spcAft>
-              <a:defRPr sz="2000">
-                <a:solidFill>
-                  <a:srgbClr val="B2BECD"/>
-                </a:solidFill>
-              </a:defRPr>
-            </a:pPr>
-            <a:r>
-              <a:t>- Maps defect to common root causes</a:t>
-            </a:r>
-          </a:p>
-          <a:p>
-            <a:pPr>
-              <a:spcAft>
-                <a:spcPts val="700"/>
-              </a:spcAft>
-              <a:defRPr sz="2000">
-                <a:solidFill>
-                  <a:srgbClr val="B2BECD"/>
-                </a:solidFill>
-              </a:defRPr>
-            </a:pPr>
-            <a:r>
-              <a:t>- Suggests corrective actions</a:t>
-            </a:r>
-          </a:p>
-          <a:p>
-            <a:pPr>
-              <a:spcAft>
-                <a:spcPts val="700"/>
-              </a:spcAft>
-              <a:defRPr sz="2000">
-                <a:solidFill>
-                  <a:srgbClr val="B2BECD"/>
-                </a:solidFill>
-              </a:defRPr>
-            </a:pPr>
-            <a:r>
-              <a:t>- Live mode overlays prediction on webcam feed</a:t>
-            </a:r>
-          </a:p>
-          <a:p>
-            <a:pPr>
-              <a:spcAft>
-                <a:spcPts val="700"/>
-              </a:spcAft>
-              <a:defRPr sz="2000">
-                <a:solidFill>
-                  <a:srgbClr val="B2BECD"/>
-                </a:solidFill>
-              </a:defRPr>
-            </a:pPr>
-            <a:r>
-              <a:t>- Helps operator decide whether to continue, pause, or inspect print</a:t>
+              <a:defRPr sz="1900">
+                <a:solidFill>
+                  <a:srgbClr val="B2BECD"/>
+                </a:solidFill>
+              </a:defRPr>
+            </a:pPr>
+            <a:r>
+              <a:t>- Predicts class, confidence, and operational risk</a:t>
+            </a:r>
+          </a:p>
+          <a:p>
+            <a:pPr>
+              <a:spcAft>
+                <a:spcPts val="700"/>
+              </a:spcAft>
+              <a:defRPr sz="1900">
+                <a:solidFill>
+                  <a:srgbClr val="B2BECD"/>
+                </a:solidFill>
+              </a:defRPr>
+            </a:pPr>
+            <a:r>
+              <a:t>- Maps defects to likely causes and corrective actions</a:t>
+            </a:r>
+          </a:p>
+          <a:p>
+            <a:pPr>
+              <a:spcAft>
+                <a:spcPts val="700"/>
+              </a:spcAft>
+              <a:defRPr sz="1900">
+                <a:solidFill>
+                  <a:srgbClr val="B2BECD"/>
+                </a:solidFill>
+              </a:defRPr>
+            </a:pPr>
+            <a:r>
+              <a:t>- Marks low-confidence frames as uncertain</a:t>
+            </a:r>
+          </a:p>
+          <a:p>
+            <a:pPr>
+              <a:spcAft>
+                <a:spcPts val="700"/>
+              </a:spcAft>
+              <a:defRPr sz="1900">
+                <a:solidFill>
+                  <a:srgbClr val="B2BECD"/>
+                </a:solidFill>
+              </a:defRPr>
+            </a:pPr>
+            <a:r>
+              <a:t>- Shows temperature and progress when OctoPrint is connected</a:t>
+            </a:r>
+          </a:p>
+          <a:p>
+            <a:pPr>
+              <a:spcAft>
+                <a:spcPts val="700"/>
+              </a:spcAft>
+              <a:defRPr sz="1900">
+                <a:solidFill>
+                  <a:srgbClr val="B2BECD"/>
+                </a:solidFill>
+              </a:defRPr>
+            </a:pPr>
+            <a:r>
+              <a:t>- Keeps unavailable values explicit instead of fabricating telemetry</a:t>
+            </a:r>
+          </a:p>
+          <a:p>
+            <a:pPr>
+              <a:spcAft>
+                <a:spcPts val="700"/>
+              </a:spcAft>
+              <a:defRPr sz="1900">
+                <a:solidFill>
+                  <a:srgbClr val="B2BECD"/>
+                </a:solidFill>
+              </a:defRPr>
+            </a:pPr>
+            <a:r>
+              <a:t>- Never moves axes or changes heaters automatically</a:t>
             </a:r>
           </a:p>
         </p:txBody>
@@ -4466,7 +4493,7 @@
               <a:spcAft>
                 <a:spcPts val="700"/>
               </a:spcAft>
-              <a:defRPr sz="2000">
+              <a:defRPr sz="1900">
                 <a:solidFill>
                   <a:srgbClr val="F2F6FA"/>
                 </a:solidFill>
@@ -4481,7 +4508,7 @@
               <a:spcAft>
                 <a:spcPts val="700"/>
               </a:spcAft>
-              <a:defRPr sz="2000">
+              <a:defRPr sz="1900">
                 <a:solidFill>
                   <a:srgbClr val="B2BECD"/>
                 </a:solidFill>
@@ -4496,44 +4523,59 @@
               <a:spcAft>
                 <a:spcPts val="700"/>
               </a:spcAft>
-              <a:defRPr sz="2000">
-                <a:solidFill>
-                  <a:srgbClr val="B2BECD"/>
-                </a:solidFill>
-              </a:defRPr>
-            </a:pPr>
-            <a:r>
-              <a:t>- Accuracy may change with new camera angle, lighting, printer, or material</a:t>
-            </a:r>
-          </a:p>
-          <a:p>
-            <a:pPr>
-              <a:spcAft>
-                <a:spcPts val="700"/>
-              </a:spcAft>
-              <a:defRPr sz="2000">
-                <a:solidFill>
-                  <a:srgbClr val="B2BECD"/>
-                </a:solidFill>
-              </a:defRPr>
-            </a:pPr>
-            <a:r>
-              <a:t>- Some defects need more labeled images</a:t>
-            </a:r>
-          </a:p>
-          <a:p>
-            <a:pPr>
-              <a:spcAft>
-                <a:spcPts val="700"/>
-              </a:spcAft>
-              <a:defRPr sz="2000">
-                <a:solidFill>
-                  <a:srgbClr val="B2BECD"/>
-                </a:solidFill>
-              </a:defRPr>
-            </a:pPr>
-            <a:r>
-              <a:t>- Live webcam mode is a prototype monitor, not closed-loop printer control</a:t>
+              <a:defRPr sz="1900">
+                <a:solidFill>
+                  <a:srgbClr val="B2BECD"/>
+                </a:solidFill>
+              </a:defRPr>
+            </a:pPr>
+            <a:r>
+              <a:t>- 96.52% is an image-level held-out result</a:t>
+            </a:r>
+          </a:p>
+          <a:p>
+            <a:pPr>
+              <a:spcAft>
+                <a:spcPts val="700"/>
+              </a:spcAft>
+              <a:defRPr sz="1900">
+                <a:solidFill>
+                  <a:srgbClr val="B2BECD"/>
+                </a:solidFill>
+              </a:defRPr>
+            </a:pPr>
+            <a:r>
+              <a:t>- Cross-printer and cross-recording generalization is not yet established</a:t>
+            </a:r>
+          </a:p>
+          <a:p>
+            <a:pPr>
+              <a:spcAft>
+                <a:spcPts val="700"/>
+              </a:spcAft>
+              <a:defRPr sz="1900">
+                <a:solidFill>
+                  <a:srgbClr val="B2BECD"/>
+                </a:solidFill>
+              </a:defRPr>
+            </a:pPr>
+            <a:r>
+              <a:t>- Accuracy may change with camera angle, lighting, printer, or material</a:t>
+            </a:r>
+          </a:p>
+          <a:p>
+            <a:pPr>
+              <a:spcAft>
+                <a:spcPts val="700"/>
+              </a:spcAft>
+              <a:defRPr sz="1900">
+                <a:solidFill>
+                  <a:srgbClr val="B2BECD"/>
+                </a:solidFill>
+              </a:defRPr>
+            </a:pPr>
+            <a:r>
+              <a:t>- Monitoring is decision support, not closed-loop control</a:t>
             </a:r>
           </a:p>
         </p:txBody>
@@ -4907,7 +4949,7 @@
               <a:spcAft>
                 <a:spcPts val="700"/>
               </a:spcAft>
-              <a:defRPr sz="2100">
+              <a:defRPr sz="1900">
                 <a:solidFill>
                   <a:srgbClr val="F2F6FA"/>
                 </a:solidFill>
@@ -4922,59 +4964,74 @@
               <a:spcAft>
                 <a:spcPts val="700"/>
               </a:spcAft>
-              <a:defRPr sz="2100">
-                <a:solidFill>
-                  <a:srgbClr val="B2BECD"/>
-                </a:solidFill>
-              </a:defRPr>
-            </a:pPr>
-            <a:r>
-              <a:t>- Built an AI system for FDM defect detection</a:t>
-            </a:r>
-          </a:p>
-          <a:p>
-            <a:pPr>
-              <a:spcAft>
-                <a:spcPts val="700"/>
-              </a:spcAft>
-              <a:defRPr sz="2100">
-                <a:solidFill>
-                  <a:srgbClr val="B2BECD"/>
-                </a:solidFill>
-              </a:defRPr>
-            </a:pPr>
-            <a:r>
-              <a:t>- EfficientNetB0 achieved 96.52% test accuracy on 8 classes</a:t>
-            </a:r>
-          </a:p>
-          <a:p>
-            <a:pPr>
-              <a:spcAft>
-                <a:spcPts val="700"/>
-              </a:spcAft>
-              <a:defRPr sz="2100">
-                <a:solidFill>
-                  <a:srgbClr val="B2BECD"/>
-                </a:solidFill>
-              </a:defRPr>
-            </a:pPr>
-            <a:r>
-              <a:t>- App supports image upload, live webcam, AI feedback, and corrective actions</a:t>
-            </a:r>
-          </a:p>
-          <a:p>
-            <a:pPr>
-              <a:spcAft>
-                <a:spcPts val="700"/>
-              </a:spcAft>
-              <a:defRPr sz="2100">
-                <a:solidFill>
-                  <a:srgbClr val="B2BECD"/>
-                </a:solidFill>
-              </a:defRPr>
-            </a:pPr>
-            <a:r>
-              <a:t>- Project aligns with CNN deep learning and AI applications in manufacturing</a:t>
+              <a:defRPr sz="1900">
+                <a:solidFill>
+                  <a:srgbClr val="B2BECD"/>
+                </a:solidFill>
+              </a:defRPr>
+            </a:pPr>
+            <a:r>
+              <a:t>- Built an eight-class AI system for FDM defect detection</a:t>
+            </a:r>
+          </a:p>
+          <a:p>
+            <a:pPr>
+              <a:spcAft>
+                <a:spcPts val="700"/>
+              </a:spcAft>
+              <a:defRPr sz="1900">
+                <a:solidFill>
+                  <a:srgbClr val="B2BECD"/>
+                </a:solidFill>
+              </a:defRPr>
+            </a:pPr>
+            <a:r>
+              <a:t>- EfficientNetB0 achieved 96.52% image-level test accuracy</a:t>
+            </a:r>
+          </a:p>
+          <a:p>
+            <a:pPr>
+              <a:spcAft>
+                <a:spcPts val="700"/>
+              </a:spcAft>
+              <a:defRPr sz="1900">
+                <a:solidFill>
+                  <a:srgbClr val="B2BECD"/>
+                </a:solidFill>
+              </a:defRPr>
+            </a:pPr>
+            <a:r>
+              <a:t>- OpenCV dashboard provides continuous monitoring and uncertainty handling</a:t>
+            </a:r>
+          </a:p>
+          <a:p>
+            <a:pPr>
+              <a:spcAft>
+                <a:spcPts val="700"/>
+              </a:spcAft>
+              <a:defRPr sz="1900">
+                <a:solidFill>
+                  <a:srgbClr val="B2BECD"/>
+                </a:solidFill>
+              </a:defRPr>
+            </a:pPr>
+            <a:r>
+              <a:t>- Explainability, feedback, and optional telemetry support operator decisions</a:t>
+            </a:r>
+          </a:p>
+          <a:p>
+            <a:pPr>
+              <a:spcAft>
+                <a:spcPts val="700"/>
+              </a:spcAft>
+              <a:defRPr sz="1900">
+                <a:solidFill>
+                  <a:srgbClr val="B2BECD"/>
+                </a:solidFill>
+              </a:defRPr>
+            </a:pPr>
+            <a:r>
+              <a:t>- External printer-session validation remains the next research step</a:t>
             </a:r>
           </a:p>
         </p:txBody>

</xml_diff>